<commit_message>
fix: validate branding clearance and document partial migration acceptance
Keep logos above titles and wrap authenticated website navigation for the longer branding. Record reproducible local evidence, exact historical exceptions and the Entra app-management blocker without claiming cloud completion.

Co-authored-by: Copilot <223556219+Copilot@users.noreply.github.com>
</commit_message>
<xml_diff>
--- a/.copilot-tracking/ppt/2026-09-11/zava-forward-cxo-introduction/final/zava-forward-cxo-executive-presentation.pptx
+++ b/.copilot-tracking/ppt/2026-09-11/zava-forward-cxo-introduction/final/zava-forward-cxo-executive-presentation.pptx
@@ -6776,8 +6776,8 @@
         </p:nvSpPr>
         <p:spPr>
           <a:xfrm>
-            <a:off x="11049000" y="109728"/>
-            <a:ext cx="960120" cy="335445"/>
+            <a:off x="11231880" y="91440"/>
+            <a:ext cx="777240" cy="271551"/>
           </a:xfrm>
           <a:prstGeom prst="rect">
             <a:avLst/>
@@ -6827,8 +6827,8 @@
         </p:blipFill>
         <p:spPr>
           <a:xfrm>
-            <a:off x="11049000" y="109728"/>
-            <a:ext cx="960120" cy="335446"/>
+            <a:off x="11231880" y="91440"/>
+            <a:ext cx="777240" cy="271551"/>
           </a:xfrm>
           <a:prstGeom prst="rect">
             <a:avLst/>
@@ -7389,8 +7389,8 @@
         </p:nvSpPr>
         <p:spPr>
           <a:xfrm>
-            <a:off x="11049000" y="109728"/>
-            <a:ext cx="960120" cy="335445"/>
+            <a:off x="11231880" y="91440"/>
+            <a:ext cx="777240" cy="271551"/>
           </a:xfrm>
           <a:prstGeom prst="rect">
             <a:avLst/>
@@ -7440,8 +7440,8 @@
         </p:blipFill>
         <p:spPr>
           <a:xfrm>
-            <a:off x="11049000" y="109728"/>
-            <a:ext cx="960120" cy="335446"/>
+            <a:off x="11231880" y="91440"/>
+            <a:ext cx="777240" cy="271551"/>
           </a:xfrm>
           <a:prstGeom prst="rect">
             <a:avLst/>
@@ -8498,8 +8498,8 @@
         </p:nvSpPr>
         <p:spPr>
           <a:xfrm>
-            <a:off x="11049000" y="109728"/>
-            <a:ext cx="960120" cy="335445"/>
+            <a:off x="11231880" y="91440"/>
+            <a:ext cx="777240" cy="271551"/>
           </a:xfrm>
           <a:prstGeom prst="rect">
             <a:avLst/>
@@ -8549,8 +8549,8 @@
         </p:blipFill>
         <p:spPr>
           <a:xfrm>
-            <a:off x="11049000" y="109728"/>
-            <a:ext cx="960120" cy="335446"/>
+            <a:off x="11231880" y="91440"/>
+            <a:ext cx="777240" cy="271551"/>
           </a:xfrm>
           <a:prstGeom prst="rect">
             <a:avLst/>
@@ -9435,8 +9435,8 @@
         </p:nvSpPr>
         <p:spPr>
           <a:xfrm>
-            <a:off x="11049000" y="109728"/>
-            <a:ext cx="960120" cy="335445"/>
+            <a:off x="11231880" y="91440"/>
+            <a:ext cx="777240" cy="271551"/>
           </a:xfrm>
           <a:prstGeom prst="rect">
             <a:avLst/>
@@ -9486,8 +9486,8 @@
         </p:blipFill>
         <p:spPr>
           <a:xfrm>
-            <a:off x="11049000" y="109728"/>
-            <a:ext cx="960120" cy="335446"/>
+            <a:off x="11231880" y="91440"/>
+            <a:ext cx="777240" cy="271551"/>
           </a:xfrm>
           <a:prstGeom prst="rect">
             <a:avLst/>
@@ -10649,8 +10649,8 @@
         </p:nvSpPr>
         <p:spPr>
           <a:xfrm>
-            <a:off x="11049000" y="109728"/>
-            <a:ext cx="960120" cy="335445"/>
+            <a:off x="11231880" y="91440"/>
+            <a:ext cx="777240" cy="271551"/>
           </a:xfrm>
           <a:prstGeom prst="rect">
             <a:avLst/>
@@ -10700,8 +10700,8 @@
         </p:blipFill>
         <p:spPr>
           <a:xfrm>
-            <a:off x="11049000" y="109728"/>
-            <a:ext cx="960120" cy="335446"/>
+            <a:off x="11231880" y="91440"/>
+            <a:ext cx="777240" cy="271551"/>
           </a:xfrm>
           <a:prstGeom prst="rect">
             <a:avLst/>
@@ -11501,8 +11501,8 @@
         </p:nvSpPr>
         <p:spPr>
           <a:xfrm>
-            <a:off x="11049000" y="109728"/>
-            <a:ext cx="960120" cy="335445"/>
+            <a:off x="11231880" y="91440"/>
+            <a:ext cx="777240" cy="271551"/>
           </a:xfrm>
           <a:prstGeom prst="rect">
             <a:avLst/>
@@ -11552,8 +11552,8 @@
         </p:blipFill>
         <p:spPr>
           <a:xfrm>
-            <a:off x="11049000" y="109728"/>
-            <a:ext cx="960120" cy="335446"/>
+            <a:off x="11231880" y="91440"/>
+            <a:ext cx="777240" cy="271551"/>
           </a:xfrm>
           <a:prstGeom prst="rect">
             <a:avLst/>
@@ -12629,8 +12629,8 @@
         </p:nvSpPr>
         <p:spPr>
           <a:xfrm>
-            <a:off x="11049000" y="109728"/>
-            <a:ext cx="960120" cy="335445"/>
+            <a:off x="11231880" y="91440"/>
+            <a:ext cx="777240" cy="271551"/>
           </a:xfrm>
           <a:prstGeom prst="rect">
             <a:avLst/>
@@ -12680,8 +12680,8 @@
         </p:blipFill>
         <p:spPr>
           <a:xfrm>
-            <a:off x="11049000" y="109728"/>
-            <a:ext cx="960120" cy="335446"/>
+            <a:off x="11231880" y="91440"/>
+            <a:ext cx="777240" cy="271551"/>
           </a:xfrm>
           <a:prstGeom prst="rect">
             <a:avLst/>
@@ -13832,8 +13832,8 @@
         </p:nvSpPr>
         <p:spPr>
           <a:xfrm>
-            <a:off x="11049000" y="109728"/>
-            <a:ext cx="960120" cy="335445"/>
+            <a:off x="11231880" y="91440"/>
+            <a:ext cx="777240" cy="271551"/>
           </a:xfrm>
           <a:prstGeom prst="rect">
             <a:avLst/>
@@ -13883,8 +13883,8 @@
         </p:blipFill>
         <p:spPr>
           <a:xfrm>
-            <a:off x="11049000" y="109728"/>
-            <a:ext cx="960120" cy="335446"/>
+            <a:off x="11231880" y="91440"/>
+            <a:ext cx="777240" cy="271551"/>
           </a:xfrm>
           <a:prstGeom prst="rect">
             <a:avLst/>
@@ -14626,8 +14626,8 @@
         </p:nvSpPr>
         <p:spPr>
           <a:xfrm>
-            <a:off x="11049000" y="109728"/>
-            <a:ext cx="960120" cy="335445"/>
+            <a:off x="11231880" y="91440"/>
+            <a:ext cx="777240" cy="271551"/>
           </a:xfrm>
           <a:prstGeom prst="rect">
             <a:avLst/>
@@ -14677,8 +14677,8 @@
         </p:blipFill>
         <p:spPr>
           <a:xfrm>
-            <a:off x="11049000" y="109728"/>
-            <a:ext cx="960120" cy="335446"/>
+            <a:off x="11231880" y="91440"/>
+            <a:ext cx="777240" cy="271551"/>
           </a:xfrm>
           <a:prstGeom prst="rect">
             <a:avLst/>
@@ -15822,8 +15822,8 @@
         </p:nvSpPr>
         <p:spPr>
           <a:xfrm>
-            <a:off x="11049000" y="109728"/>
-            <a:ext cx="960120" cy="335445"/>
+            <a:off x="11231880" y="91440"/>
+            <a:ext cx="777240" cy="271551"/>
           </a:xfrm>
           <a:prstGeom prst="rect">
             <a:avLst/>
@@ -15873,8 +15873,8 @@
         </p:blipFill>
         <p:spPr>
           <a:xfrm>
-            <a:off x="11049000" y="109728"/>
-            <a:ext cx="960120" cy="335446"/>
+            <a:off x="11231880" y="91440"/>
+            <a:ext cx="777240" cy="271551"/>
           </a:xfrm>
           <a:prstGeom prst="rect">
             <a:avLst/>
@@ -16988,8 +16988,8 @@
         </p:nvSpPr>
         <p:spPr>
           <a:xfrm>
-            <a:off x="11049000" y="109728"/>
-            <a:ext cx="960120" cy="335445"/>
+            <a:off x="11231880" y="91440"/>
+            <a:ext cx="777240" cy="271551"/>
           </a:xfrm>
           <a:prstGeom prst="rect">
             <a:avLst/>
@@ -17039,8 +17039,8 @@
         </p:blipFill>
         <p:spPr>
           <a:xfrm>
-            <a:off x="11049000" y="109728"/>
-            <a:ext cx="960120" cy="335446"/>
+            <a:off x="11231880" y="91440"/>
+            <a:ext cx="777240" cy="271551"/>
           </a:xfrm>
           <a:prstGeom prst="rect">
             <a:avLst/>
@@ -17553,8 +17553,8 @@
         </p:nvSpPr>
         <p:spPr>
           <a:xfrm>
-            <a:off x="11049000" y="109728"/>
-            <a:ext cx="960120" cy="335445"/>
+            <a:off x="11231880" y="91440"/>
+            <a:ext cx="777240" cy="271551"/>
           </a:xfrm>
           <a:prstGeom prst="rect">
             <a:avLst/>
@@ -17604,8 +17604,8 @@
         </p:blipFill>
         <p:spPr>
           <a:xfrm>
-            <a:off x="11049000" y="109728"/>
-            <a:ext cx="960120" cy="335446"/>
+            <a:off x="11231880" y="91440"/>
+            <a:ext cx="777240" cy="271551"/>
           </a:xfrm>
           <a:prstGeom prst="rect">
             <a:avLst/>
@@ -18499,8 +18499,8 @@
         </p:nvSpPr>
         <p:spPr>
           <a:xfrm>
-            <a:off x="11049000" y="109728"/>
-            <a:ext cx="960120" cy="335445"/>
+            <a:off x="11231880" y="91440"/>
+            <a:ext cx="777240" cy="271551"/>
           </a:xfrm>
           <a:prstGeom prst="rect">
             <a:avLst/>
@@ -18550,8 +18550,8 @@
         </p:blipFill>
         <p:spPr>
           <a:xfrm>
-            <a:off x="11049000" y="109728"/>
-            <a:ext cx="960120" cy="335446"/>
+            <a:off x="11231880" y="91440"/>
+            <a:ext cx="777240" cy="271551"/>
           </a:xfrm>
           <a:prstGeom prst="rect">
             <a:avLst/>
@@ -19434,8 +19434,8 @@
         </p:nvSpPr>
         <p:spPr>
           <a:xfrm>
-            <a:off x="11049000" y="109728"/>
-            <a:ext cx="960120" cy="335445"/>
+            <a:off x="11231880" y="91440"/>
+            <a:ext cx="777240" cy="271551"/>
           </a:xfrm>
           <a:prstGeom prst="rect">
             <a:avLst/>
@@ -19485,8 +19485,8 @@
         </p:blipFill>
         <p:spPr>
           <a:xfrm>
-            <a:off x="11049000" y="109728"/>
-            <a:ext cx="960120" cy="335446"/>
+            <a:off x="11231880" y="91440"/>
+            <a:ext cx="777240" cy="271551"/>
           </a:xfrm>
           <a:prstGeom prst="rect">
             <a:avLst/>

</xml_diff>